<commit_message>
Add GRU results, refreshed attack/evaluate for all five models, regenerate documents
Bi-GRU: 92.9% accuracy, 88.1% obfuscated recall - below the CNN, so order
and long-range context do not beat convolution on this data.

Packet-space black-box attack on freshly generated malicious flows:
CNN 4.0% -> 14.1% evasion at 158% byte overhead; MLP 1.5% -> 9.1% at 8%;
GRU 4.5% -> 19.2% at 78%; hybrid 2.0% -> 10.1% at 78%; defended hybrid
2.0% -> 10.6% at 86%. Adversarial training does not carry over to this
attack even though it more than halves gradient-PGD evasion - the two
attacks take different paths, and a defense evaluated only against the
attack it was trained on would look far better than it is. Recorded in
FUTURE_WORK as the next defense experiment.

Five-way transfer matrix on a 1,000-flow subsample; defended hybrid holds
90-95% against examples crafted on any other model.

Report, book chapter and deck regenerated from the final numbers.
PROJECT.md gains a headline-results table.
</commit_message>
<xml_diff>
--- a/docs/ANTOD_presentation.pptx
+++ b/docs/ANTOD_presentation.pptx
@@ -206,9 +206,9 @@
           </c:dLbls>
           <c:cat>
             <c:multiLvlStrRef>
-              <c:f>Sheet1!$A$2:$A$8</c:f>
+              <c:f>Sheet1!$A$2:$A$9</c:f>
               <c:multiLvlStrCache>
-                <c:ptCount val="7"/>
+                <c:ptCount val="8"/>
                 <c:lvl>
                   <c:pt idx="0">
                     <c:v>1D-CNN</c:v>
@@ -217,18 +217,21 @@
                     <c:v>MLP</c:v>
                   </c:pt>
                   <c:pt idx="2">
+                    <c:v>Bi-GRU</c:v>
+                  </c:pt>
+                  <c:pt idx="3">
                     <c:v>Hybrid</c:v>
                   </c:pt>
-                  <c:pt idx="3">
+                  <c:pt idx="4">
                     <c:v>Hybrid + adv. training</c:v>
                   </c:pt>
-                  <c:pt idx="4">
+                  <c:pt idx="5">
                     <c:v>Random forest</c:v>
                   </c:pt>
-                  <c:pt idx="5">
+                  <c:pt idx="6">
                     <c:v>RBF SVM</c:v>
                   </c:pt>
-                  <c:pt idx="6">
+                  <c:pt idx="7">
                     <c:v>Logistic reg.</c:v>
                   </c:pt>
                 </c:lvl>
@@ -237,10 +240,10 @@
           </c:cat>
           <c:val>
             <c:numRef>
-              <c:f>Sheet1!$B$2:$B$8</c:f>
+              <c:f>Sheet1!$B$2:$B$9</c:f>
               <c:numCache>
                 <c:formatCode>General</c:formatCode>
-                <c:ptCount val="7"/>
+                <c:ptCount val="8"/>
                 <c:pt idx="0">
                   <c:v>0.941</c:v>
                 </c:pt>
@@ -248,18 +251,21 @@
                   <c:v>0.9618</c:v>
                 </c:pt>
                 <c:pt idx="2">
+                  <c:v>0.9293</c:v>
+                </c:pt>
+                <c:pt idx="3">
                   <c:v>0.9688</c:v>
                 </c:pt>
-                <c:pt idx="3">
+                <c:pt idx="4">
                   <c:v>0.965</c:v>
                 </c:pt>
-                <c:pt idx="4">
+                <c:pt idx="5">
                   <c:v>0.9723</c:v>
                 </c:pt>
-                <c:pt idx="5">
+                <c:pt idx="6">
                   <c:v>0.9683</c:v>
                 </c:pt>
-                <c:pt idx="6">
+                <c:pt idx="7">
                   <c:v>0.922</c:v>
                 </c:pt>
               </c:numCache>
@@ -313,9 +319,9 @@
           </c:dLbls>
           <c:cat>
             <c:multiLvlStrRef>
-              <c:f>Sheet1!$A$2:$A$8</c:f>
+              <c:f>Sheet1!$A$2:$A$9</c:f>
               <c:multiLvlStrCache>
-                <c:ptCount val="7"/>
+                <c:ptCount val="8"/>
                 <c:lvl>
                   <c:pt idx="0">
                     <c:v>1D-CNN</c:v>
@@ -324,18 +330,21 @@
                     <c:v>MLP</c:v>
                   </c:pt>
                   <c:pt idx="2">
+                    <c:v>Bi-GRU</c:v>
+                  </c:pt>
+                  <c:pt idx="3">
                     <c:v>Hybrid</c:v>
                   </c:pt>
-                  <c:pt idx="3">
+                  <c:pt idx="4">
                     <c:v>Hybrid + adv. training</c:v>
                   </c:pt>
-                  <c:pt idx="4">
+                  <c:pt idx="5">
                     <c:v>Random forest</c:v>
                   </c:pt>
-                  <c:pt idx="5">
+                  <c:pt idx="6">
                     <c:v>RBF SVM</c:v>
                   </c:pt>
-                  <c:pt idx="6">
+                  <c:pt idx="7">
                     <c:v>Logistic reg.</c:v>
                   </c:pt>
                 </c:lvl>
@@ -344,10 +353,10 @@
           </c:cat>
           <c:val>
             <c:numRef>
-              <c:f>Sheet1!$C$2:$C$8</c:f>
+              <c:f>Sheet1!$C$2:$C$9</c:f>
               <c:numCache>
                 <c:formatCode>General</c:formatCode>
-                <c:ptCount val="7"/>
+                <c:ptCount val="8"/>
                 <c:pt idx="0">
                   <c:v>0.8856</c:v>
                 </c:pt>
@@ -355,18 +364,21 @@
                   <c:v>0.9311</c:v>
                 </c:pt>
                 <c:pt idx="2">
-                  <c:v>0.9424</c:v>
+                  <c:v>0.8811</c:v>
                 </c:pt>
                 <c:pt idx="3">
                   <c:v>0.9424</c:v>
                 </c:pt>
                 <c:pt idx="4">
+                  <c:v>0.9424</c:v>
+                </c:pt>
+                <c:pt idx="5">
                   <c:v>0.9492</c:v>
                 </c:pt>
-                <c:pt idx="5">
+                <c:pt idx="6">
                   <c:v>0.9386</c:v>
                 </c:pt>
-                <c:pt idx="6">
+                <c:pt idx="7">
                   <c:v>0.8568</c:v>
                 </c:pt>
               </c:numCache>
@@ -834,7 +846,7 @@
               <c:strCache>
                 <c:ptCount val="1"/>
                 <c:pt idx="0">
-                  <c:v>Hybrid</c:v>
+                  <c:v>Bi-GRU</c:v>
                 </c:pt>
               </c:strCache>
             </c:strRef>
@@ -929,22 +941,22 @@
                 <c:formatCode>General</c:formatCode>
                 <c:ptCount val="6"/>
                 <c:pt idx="0">
-                  <c:v>0.9688</c:v>
+                  <c:v>0.93</c:v>
                 </c:pt>
                 <c:pt idx="1">
-                  <c:v>0.959</c:v>
+                  <c:v>0.806</c:v>
                 </c:pt>
                 <c:pt idx="2">
-                  <c:v>0.911</c:v>
+                  <c:v>0.57</c:v>
                 </c:pt>
                 <c:pt idx="3">
-                  <c:v>0.7276</c:v>
+                  <c:v>0.486</c:v>
                 </c:pt>
                 <c:pt idx="4">
-                  <c:v>0.4016</c:v>
+                  <c:v>0.418</c:v>
                 </c:pt>
                 <c:pt idx="5">
-                  <c:v>0.2417</c:v>
+                  <c:v>0.382</c:v>
                 </c:pt>
               </c:numCache>
             </c:numRef>
@@ -960,7 +972,7 @@
               <c:strCache>
                 <c:ptCount val="1"/>
                 <c:pt idx="0">
-                  <c:v>Hybrid + adv. training</c:v>
+                  <c:v>Hybrid</c:v>
                 </c:pt>
               </c:strCache>
             </c:strRef>
@@ -1051,6 +1063,132 @@
           <c:val>
             <c:numRef>
               <c:f>Sheet1!$E$2:$E$7</c:f>
+              <c:numCache>
+                <c:formatCode>General</c:formatCode>
+                <c:ptCount val="6"/>
+                <c:pt idx="0">
+                  <c:v>0.9688</c:v>
+                </c:pt>
+                <c:pt idx="1">
+                  <c:v>0.959</c:v>
+                </c:pt>
+                <c:pt idx="2">
+                  <c:v>0.911</c:v>
+                </c:pt>
+                <c:pt idx="3">
+                  <c:v>0.7276</c:v>
+                </c:pt>
+                <c:pt idx="4">
+                  <c:v>0.4016</c:v>
+                </c:pt>
+                <c:pt idx="5">
+                  <c:v>0.2417</c:v>
+                </c:pt>
+              </c:numCache>
+            </c:numRef>
+          </c:val>
+          <c:smooth val="0"/>
+        </c:ser>
+        <c:ser>
+          <c:idx val="4"/>
+          <c:order val="4"/>
+          <c:tx>
+            <c:strRef>
+              <c:f>Sheet1!$F$1</c:f>
+              <c:strCache>
+                <c:ptCount val="1"/>
+                <c:pt idx="0">
+                  <c:v>Hybrid + adv. training</c:v>
+                </c:pt>
+              </c:strCache>
+            </c:strRef>
+          </c:tx>
+          <c:spPr>
+            <a:solidFill>
+              <a:srgbClr val="4A3AA7"/>
+            </a:solidFill>
+            <a:ln w="25400" cap="flat">
+              <a:solidFill>
+                <a:srgbClr val="4A3AA7"/>
+              </a:solidFill>
+              <a:prstDash val="solid"/>
+              <a:round/>
+            </a:ln>
+            <a:effectLst/>
+          </c:spPr>
+          <c:invertIfNegative val="0"/>
+          <c:dLbls>
+            <c:numFmt formatCode="#,##0" sourceLinked="0"/>
+            <c:txPr>
+              <a:bodyPr/>
+              <a:lstStyle/>
+              <a:p>
+                <a:pPr>
+                  <a:defRPr b="0" i="0" strike="noStrike" sz="1200" u="none">
+                    <a:solidFill>
+                      <a:srgbClr val="000000"/>
+                    </a:solidFill>
+                    <a:latin typeface="Arial"/>
+                  </a:defRPr>
+                </a:pPr>
+              </a:p>
+            </c:txPr>
+            <c:showLegendKey val="0"/>
+            <c:showVal val="0"/>
+            <c:showCatName val="0"/>
+            <c:showSerName val="0"/>
+            <c:showPercent val="0"/>
+            <c:showBubbleSize val="0"/>
+            <c:showLeaderLines val="0"/>
+          </c:dLbls>
+          <c:marker>
+            <c:symbol val="circle"/>
+            <c:size val="6"/>
+            <c:spPr>
+              <a:solidFill>
+                <a:srgbClr val="4A3AA7"/>
+              </a:solidFill>
+              <a:ln w="9525" cap="flat">
+                <a:solidFill>
+                  <a:srgbClr val="4A3AA7"/>
+                </a:solidFill>
+                <a:prstDash val="solid"/>
+                <a:round/>
+              </a:ln>
+              <a:effectLst/>
+            </c:spPr>
+          </c:marker>
+          <c:cat>
+            <c:multiLvlStrRef>
+              <c:f>Sheet1!$A$2:$A$7</c:f>
+              <c:multiLvlStrCache>
+                <c:ptCount val="6"/>
+                <c:lvl>
+                  <c:pt idx="0">
+                    <c:v>0</c:v>
+                  </c:pt>
+                  <c:pt idx="1">
+                    <c:v>0.02</c:v>
+                  </c:pt>
+                  <c:pt idx="2">
+                    <c:v>0.05</c:v>
+                  </c:pt>
+                  <c:pt idx="3">
+                    <c:v>0.1</c:v>
+                  </c:pt>
+                  <c:pt idx="4">
+                    <c:v>0.2</c:v>
+                  </c:pt>
+                  <c:pt idx="5">
+                    <c:v>0.3</c:v>
+                  </c:pt>
+                </c:lvl>
+              </c:multiLvlStrCache>
+            </c:multiLvlStrRef>
+          </c:cat>
+          <c:val>
+            <c:numRef>
+              <c:f>Sheet1!$F$2:$F$7</c:f>
               <c:numCache>
                 <c:formatCode>General</c:formatCode>
                 <c:ptCount val="6"/>
@@ -3272,7 +3410,7 @@
         <p:spPr>
           <a:xfrm>
             <a:off x="457200" y="1463040"/>
-            <a:ext cx="3931920" cy="457200"/>
+            <a:ext cx="1920240" cy="822960"/>
           </a:xfrm>
           <a:prstGeom prst="rect">
             <a:avLst/>
@@ -3284,11 +3422,50 @@
           <a:bodyPr wrap="square" lIns="0" tIns="0" rIns="0" bIns="0" rtlCol="0" anchor="ctr"/>
           <a:lstStyle/>
           <a:p>
-            <a:pPr indent="0" marL="0">
+            <a:pPr algn="ctr" indent="0" marL="0">
               <a:buNone/>
             </a:pPr>
             <a:r>
-              <a:rPr lang="en-US" sz="1200" dirty="0">
+              <a:rPr lang="en-US" sz="4000" b="1" dirty="0">
+                <a:solidFill>
+                  <a:srgbClr val="EB6834"/>
+                </a:solidFill>
+                <a:latin typeface="Cambria" pitchFamily="34" charset="0"/>
+                <a:ea typeface="Cambria" pitchFamily="34" charset="-122"/>
+                <a:cs typeface="Cambria" pitchFamily="34" charset="-120"/>
+              </a:rPr>
+              <a:t>11%</a:t>
+            </a:r>
+            <a:endParaRPr lang="en-US" sz="4000" dirty="0"/>
+          </a:p>
+        </p:txBody>
+      </p:sp>
+      <p:sp>
+        <p:nvSpPr>
+          <p:cNvPr id="5" name="Text 3"/>
+          <p:cNvSpPr txBox="1"/>
+          <p:nvPr/>
+        </p:nvSpPr>
+        <p:spPr>
+          <a:xfrm>
+            <a:off x="457200" y="2286000"/>
+            <a:ext cx="1920240" cy="457200"/>
+          </a:xfrm>
+          <a:prstGeom prst="rect">
+            <a:avLst/>
+          </a:prstGeom>
+          <a:noFill/>
+          <a:ln/>
+        </p:spPr>
+        <p:txBody>
+          <a:bodyPr wrap="square" lIns="0" tIns="0" rIns="0" bIns="0" rtlCol="0" anchor="t"/>
+          <a:lstStyle/>
+          <a:p>
+            <a:pPr algn="ctr" indent="0" marL="0">
+              <a:buNone/>
+            </a:pPr>
+            <a:r>
+              <a:rPr lang="en-US" sz="1100" dirty="0">
                 <a:solidFill>
                   <a:srgbClr val="5C6470"/>
                 </a:solidFill>
@@ -3296,48 +3473,26 @@
                 <a:ea typeface="Calibri" pitchFamily="34" charset="-122"/>
                 <a:cs typeface="Calibri" pitchFamily="34" charset="-120"/>
               </a:rPr>
-              <a:t>Run antod attack to populate.</a:t>
-            </a:r>
-            <a:endParaRPr lang="en-US" sz="1200" dirty="0"/>
-          </a:p>
-        </p:txBody>
-      </p:sp>
-      <p:sp>
-        <p:nvSpPr>
-          <p:cNvPr id="5" name="Text 3"/>
-          <p:cNvSpPr txBox="1"/>
-          <p:nvPr/>
-        </p:nvSpPr>
-        <p:spPr>
-          <a:xfrm>
-            <a:off x="4846320" y="1051560"/>
-            <a:ext cx="3840480" cy="365760"/>
-          </a:xfrm>
-          <a:prstGeom prst="rect">
-            <a:avLst/>
-          </a:prstGeom>
-          <a:noFill/>
-          <a:ln/>
-        </p:spPr>
-        <p:txBody>
-          <a:bodyPr wrap="square" lIns="0" tIns="0" rIns="0" bIns="0" rtlCol="0" anchor="ctr"/>
-          <a:lstStyle/>
-          <a:p>
-            <a:pPr indent="0" marL="0">
+              <a:t>malicious flows walked to 'benign'</a:t>
+            </a:r>
+            <a:endParaRPr lang="en-US" sz="1100" dirty="0"/>
+          </a:p>
+          <a:p>
+            <a:pPr algn="ctr" indent="0" marL="0">
               <a:buNone/>
             </a:pPr>
             <a:r>
-              <a:rPr lang="en-US" sz="1400" b="1" dirty="0">
-                <a:solidFill>
-                  <a:srgbClr val="14213D"/>
+              <a:rPr lang="en-US" sz="1100" dirty="0">
+                <a:solidFill>
+                  <a:srgbClr val="5C6470"/>
                 </a:solidFill>
                 <a:latin typeface="Calibri" pitchFamily="34" charset="0"/>
                 <a:ea typeface="Calibri" pitchFamily="34" charset="-122"/>
                 <a:cs typeface="Calibri" pitchFamily="34" charset="-120"/>
               </a:rPr>
-              <a:t>Base-rate reality</a:t>
-            </a:r>
-            <a:endParaRPr lang="en-US" sz="1400" dirty="0"/>
+              <a:t>with legal pad/delay edits</a:t>
+            </a:r>
+            <a:endParaRPr lang="en-US" sz="1100" dirty="0"/>
           </a:p>
         </p:txBody>
       </p:sp>
@@ -3349,8 +3504,8 @@
         </p:nvSpPr>
         <p:spPr>
           <a:xfrm>
-            <a:off x="4846320" y="1463040"/>
-            <a:ext cx="1828800" cy="822960"/>
+            <a:off x="2468880" y="1463040"/>
+            <a:ext cx="1920240" cy="822960"/>
           </a:xfrm>
           <a:prstGeom prst="rect">
             <a:avLst/>
@@ -3368,13 +3523,13 @@
             <a:r>
               <a:rPr lang="en-US" sz="4000" b="1" dirty="0">
                 <a:solidFill>
-                  <a:srgbClr val="EB6834"/>
+                  <a:srgbClr val="2A78D6"/>
                 </a:solidFill>
                 <a:latin typeface="Cambria" pitchFamily="34" charset="0"/>
                 <a:ea typeface="Cambria" pitchFamily="34" charset="-122"/>
                 <a:cs typeface="Cambria" pitchFamily="34" charset="-120"/>
               </a:rPr>
-              <a:t>18%</a:t>
+              <a:t>86%</a:t>
             </a:r>
             <a:endParaRPr lang="en-US" sz="4000" dirty="0"/>
           </a:p>
@@ -3388,8 +3543,8 @@
         </p:nvSpPr>
         <p:spPr>
           <a:xfrm>
-            <a:off x="4846320" y="2286000"/>
-            <a:ext cx="1828800" cy="457200"/>
+            <a:off x="2468880" y="2286000"/>
+            <a:ext cx="1920240" cy="457200"/>
           </a:xfrm>
           <a:prstGeom prst="rect">
             <a:avLst/>
@@ -3413,7 +3568,7 @@
                 <a:ea typeface="Calibri" pitchFamily="34" charset="-122"/>
                 <a:cs typeface="Calibri" pitchFamily="34" charset="-120"/>
               </a:rPr>
-              <a:t>precision when 99% of</a:t>
+              <a:t>extra bytes the attacker</a:t>
             </a:r>
             <a:endParaRPr lang="en-US" sz="1100" dirty="0"/>
           </a:p>
@@ -3430,7 +3585,7 @@
                 <a:ea typeface="Calibri" pitchFamily="34" charset="-122"/>
                 <a:cs typeface="Calibri" pitchFamily="34" charset="-120"/>
               </a:rPr>
-              <a:t>traffic is benign</a:t>
+              <a:t>had to pay, on average</a:t>
             </a:r>
             <a:endParaRPr lang="en-US" sz="1100" dirty="0"/>
           </a:p>
@@ -3444,8 +3599,8 @@
         </p:nvSpPr>
         <p:spPr>
           <a:xfrm>
-            <a:off x="6766560" y="1463040"/>
-            <a:ext cx="1828800" cy="822960"/>
+            <a:off x="457200" y="2926080"/>
+            <a:ext cx="3931920" cy="868680"/>
           </a:xfrm>
           <a:prstGeom prst="rect">
             <a:avLst/>
@@ -3457,19 +3612,97 @@
           <a:bodyPr wrap="square" lIns="0" tIns="0" rIns="0" bIns="0" rtlCol="0" anchor="ctr"/>
           <a:lstStyle/>
           <a:p>
+            <a:pPr indent="0" marL="0">
+              <a:buNone/>
+            </a:pPr>
+            <a:r>
+              <a:rPr lang="en-US" sz="1050" dirty="0">
+                <a:solidFill>
+                  <a:srgbClr val="5C6470"/>
+                </a:solidFill>
+                <a:latin typeface="Calibri" pitchFamily="34" charset="0"/>
+                <a:ea typeface="Calibri" pitchFamily="34" charset="-122"/>
+                <a:cs typeface="Calibri" pitchFamily="34" charset="-120"/>
+              </a:rPr>
+              <a:t>hybrid_advtrain: 198 flows, &lt;=150 queries each, 31 queries per successful evasion. Undefended hybrid: 10% - adversarial training did not help against this search, unlike gradient PGD.</a:t>
+            </a:r>
+            <a:endParaRPr lang="en-US" sz="1050" dirty="0"/>
+          </a:p>
+        </p:txBody>
+      </p:sp>
+      <p:sp>
+        <p:nvSpPr>
+          <p:cNvPr id="9" name="Text 7"/>
+          <p:cNvSpPr txBox="1"/>
+          <p:nvPr/>
+        </p:nvSpPr>
+        <p:spPr>
+          <a:xfrm>
+            <a:off x="4846320" y="1051560"/>
+            <a:ext cx="3840480" cy="365760"/>
+          </a:xfrm>
+          <a:prstGeom prst="rect">
+            <a:avLst/>
+          </a:prstGeom>
+          <a:noFill/>
+          <a:ln/>
+        </p:spPr>
+        <p:txBody>
+          <a:bodyPr wrap="square" lIns="0" tIns="0" rIns="0" bIns="0" rtlCol="0" anchor="ctr"/>
+          <a:lstStyle/>
+          <a:p>
+            <a:pPr indent="0" marL="0">
+              <a:buNone/>
+            </a:pPr>
+            <a:r>
+              <a:rPr lang="en-US" sz="1400" b="1" dirty="0">
+                <a:solidFill>
+                  <a:srgbClr val="14213D"/>
+                </a:solidFill>
+                <a:latin typeface="Calibri" pitchFamily="34" charset="0"/>
+                <a:ea typeface="Calibri" pitchFamily="34" charset="-122"/>
+                <a:cs typeface="Calibri" pitchFamily="34" charset="-120"/>
+              </a:rPr>
+              <a:t>Base-rate reality</a:t>
+            </a:r>
+            <a:endParaRPr lang="en-US" sz="1400" dirty="0"/>
+          </a:p>
+        </p:txBody>
+      </p:sp>
+      <p:sp>
+        <p:nvSpPr>
+          <p:cNvPr id="10" name="Text 8"/>
+          <p:cNvSpPr txBox="1"/>
+          <p:nvPr/>
+        </p:nvSpPr>
+        <p:spPr>
+          <a:xfrm>
+            <a:off x="4846320" y="1463040"/>
+            <a:ext cx="1828800" cy="822960"/>
+          </a:xfrm>
+          <a:prstGeom prst="rect">
+            <a:avLst/>
+          </a:prstGeom>
+          <a:noFill/>
+          <a:ln/>
+        </p:spPr>
+        <p:txBody>
+          <a:bodyPr wrap="square" lIns="0" tIns="0" rIns="0" bIns="0" rtlCol="0" anchor="ctr"/>
+          <a:lstStyle/>
+          <a:p>
             <a:pPr algn="ctr" indent="0" marL="0">
               <a:buNone/>
             </a:pPr>
             <a:r>
               <a:rPr lang="en-US" sz="4000" b="1" dirty="0">
                 <a:solidFill>
-                  <a:srgbClr val="2A78D6"/>
+                  <a:srgbClr val="EB6834"/>
                 </a:solidFill>
                 <a:latin typeface="Cambria" pitchFamily="34" charset="0"/>
                 <a:ea typeface="Cambria" pitchFamily="34" charset="-122"/>
                 <a:cs typeface="Cambria" pitchFamily="34" charset="-120"/>
               </a:rPr>
-              <a:t>444</a:t>
+              <a:t>18%</a:t>
             </a:r>
             <a:endParaRPr lang="en-US" sz="4000" dirty="0"/>
           </a:p>
@@ -3477,13 +3710,13 @@
       </p:sp>
       <p:sp>
         <p:nvSpPr>
-          <p:cNvPr id="9" name="Text 7"/>
+          <p:cNvPr id="11" name="Text 9"/>
           <p:cNvSpPr txBox="1"/>
           <p:nvPr/>
         </p:nvSpPr>
         <p:spPr>
           <a:xfrm>
-            <a:off x="6766560" y="2286000"/>
+            <a:off x="4846320" y="2286000"/>
             <a:ext cx="1828800" cy="457200"/>
           </a:xfrm>
           <a:prstGeom prst="rect">
@@ -3508,7 +3741,7 @@
                 <a:ea typeface="Calibri" pitchFamily="34" charset="-122"/>
                 <a:cs typeface="Calibri" pitchFamily="34" charset="-120"/>
               </a:rPr>
-              <a:t>false alerts per</a:t>
+              <a:t>precision when 99% of</a:t>
             </a:r>
             <a:endParaRPr lang="en-US" sz="1100" dirty="0"/>
           </a:p>
@@ -3525,7 +3758,7 @@
                 <a:ea typeface="Calibri" pitchFamily="34" charset="-122"/>
                 <a:cs typeface="Calibri" pitchFamily="34" charset="-120"/>
               </a:rPr>
-              <a:t>10,000 flows</a:t>
+              <a:t>traffic is benign</a:t>
             </a:r>
             <a:endParaRPr lang="en-US" sz="1100" dirty="0"/>
           </a:p>
@@ -3533,14 +3766,14 @@
       </p:sp>
       <p:sp>
         <p:nvSpPr>
-          <p:cNvPr id="10" name="Text 8"/>
+          <p:cNvPr id="12" name="Text 10"/>
           <p:cNvSpPr txBox="1"/>
           <p:nvPr/>
         </p:nvSpPr>
         <p:spPr>
           <a:xfrm>
-            <a:off x="4846320" y="2926080"/>
-            <a:ext cx="3840480" cy="822960"/>
+            <a:off x="6766560" y="1463040"/>
+            <a:ext cx="1828800" cy="822960"/>
           </a:xfrm>
           <a:prstGeom prst="rect">
             <a:avLst/>
@@ -3552,7 +3785,46 @@
           <a:bodyPr wrap="square" lIns="0" tIns="0" rIns="0" bIns="0" rtlCol="0" anchor="ctr"/>
           <a:lstStyle/>
           <a:p>
-            <a:pPr indent="0" marL="0">
+            <a:pPr algn="ctr" indent="0" marL="0">
+              <a:buNone/>
+            </a:pPr>
+            <a:r>
+              <a:rPr lang="en-US" sz="4000" b="1" dirty="0">
+                <a:solidFill>
+                  <a:srgbClr val="2A78D6"/>
+                </a:solidFill>
+                <a:latin typeface="Cambria" pitchFamily="34" charset="0"/>
+                <a:ea typeface="Cambria" pitchFamily="34" charset="-122"/>
+                <a:cs typeface="Cambria" pitchFamily="34" charset="-120"/>
+              </a:rPr>
+              <a:t>444</a:t>
+            </a:r>
+            <a:endParaRPr lang="en-US" sz="4000" dirty="0"/>
+          </a:p>
+        </p:txBody>
+      </p:sp>
+      <p:sp>
+        <p:nvSpPr>
+          <p:cNvPr id="13" name="Text 11"/>
+          <p:cNvSpPr txBox="1"/>
+          <p:nvPr/>
+        </p:nvSpPr>
+        <p:spPr>
+          <a:xfrm>
+            <a:off x="6766560" y="2286000"/>
+            <a:ext cx="1828800" cy="457200"/>
+          </a:xfrm>
+          <a:prstGeom prst="rect">
+            <a:avLst/>
+          </a:prstGeom>
+          <a:noFill/>
+          <a:ln/>
+        </p:spPr>
+        <p:txBody>
+          <a:bodyPr wrap="square" lIns="0" tIns="0" rIns="0" bIns="0" rtlCol="0" anchor="t"/>
+          <a:lstStyle/>
+          <a:p>
+            <a:pPr algn="ctr" indent="0" marL="0">
               <a:buNone/>
             </a:pPr>
             <a:r>
@@ -3564,6 +3836,62 @@
                 <a:ea typeface="Calibri" pitchFamily="34" charset="-122"/>
                 <a:cs typeface="Calibri" pitchFamily="34" charset="-120"/>
               </a:rPr>
+              <a:t>false alerts per</a:t>
+            </a:r>
+            <a:endParaRPr lang="en-US" sz="1100" dirty="0"/>
+          </a:p>
+          <a:p>
+            <a:pPr algn="ctr" indent="0" marL="0">
+              <a:buNone/>
+            </a:pPr>
+            <a:r>
+              <a:rPr lang="en-US" sz="1100" dirty="0">
+                <a:solidFill>
+                  <a:srgbClr val="5C6470"/>
+                </a:solidFill>
+                <a:latin typeface="Calibri" pitchFamily="34" charset="0"/>
+                <a:ea typeface="Calibri" pitchFamily="34" charset="-122"/>
+                <a:cs typeface="Calibri" pitchFamily="34" charset="-120"/>
+              </a:rPr>
+              <a:t>10,000 flows</a:t>
+            </a:r>
+            <a:endParaRPr lang="en-US" sz="1100" dirty="0"/>
+          </a:p>
+        </p:txBody>
+      </p:sp>
+      <p:sp>
+        <p:nvSpPr>
+          <p:cNvPr id="14" name="Text 12"/>
+          <p:cNvSpPr txBox="1"/>
+          <p:nvPr/>
+        </p:nvSpPr>
+        <p:spPr>
+          <a:xfrm>
+            <a:off x="4846320" y="2926080"/>
+            <a:ext cx="3840480" cy="822960"/>
+          </a:xfrm>
+          <a:prstGeom prst="rect">
+            <a:avLst/>
+          </a:prstGeom>
+          <a:noFill/>
+          <a:ln/>
+        </p:spPr>
+        <p:txBody>
+          <a:bodyPr wrap="square" lIns="0" tIns="0" rIns="0" bIns="0" rtlCol="0" anchor="ctr"/>
+          <a:lstStyle/>
+          <a:p>
+            <a:pPr indent="0" marL="0">
+              <a:buNone/>
+            </a:pPr>
+            <a:r>
+              <a:rPr lang="en-US" sz="1100" dirty="0">
+                <a:solidFill>
+                  <a:srgbClr val="5C6470"/>
+                </a:solidFill>
+                <a:latin typeface="Calibri" pitchFamily="34" charset="0"/>
+                <a:ea typeface="Calibri" pitchFamily="34" charset="-122"/>
+                <a:cs typeface="Calibri" pitchFamily="34" charset="-120"/>
+              </a:rPr>
               <a:t>The balanced test set has 34% benign traffic; real networks are &gt;99%. The same FPR of 4.5% that looks harmless on a balanced set is what this becomes in deployment.</a:t>
             </a:r>
             <a:endParaRPr lang="en-US" sz="1100" dirty="0"/>
@@ -3572,7 +3900,7 @@
       </p:sp>
       <p:sp>
         <p:nvSpPr>
-          <p:cNvPr id="11" name="Shape 9"/>
+          <p:cNvPr id="15" name="Shape 13"/>
           <p:cNvSpPr/>
           <p:nvPr/>
         </p:nvSpPr>
@@ -3599,7 +3927,7 @@
       </p:sp>
       <p:sp>
         <p:nvSpPr>
-          <p:cNvPr id="12" name="Text 10"/>
+          <p:cNvPr id="16" name="Text 14"/>
           <p:cNvSpPr txBox="1"/>
           <p:nvPr/>
         </p:nvSpPr>
@@ -7865,7 +8193,7 @@
         <p:spPr>
           <a:xfrm>
             <a:off x="502920" y="2926080"/>
-            <a:ext cx="2651760" cy="1737360"/>
+            <a:ext cx="1965960" cy="1737360"/>
           </a:xfrm>
           <a:prstGeom prst="roundRect">
             <a:avLst>
@@ -7892,7 +8220,7 @@
         <p:spPr>
           <a:xfrm>
             <a:off x="640080" y="3017520"/>
-            <a:ext cx="2377440" cy="365760"/>
+            <a:ext cx="1691640" cy="365760"/>
           </a:xfrm>
           <a:prstGeom prst="rect">
             <a:avLst/>
@@ -7931,7 +8259,7 @@
         <p:spPr>
           <a:xfrm>
             <a:off x="640080" y="3383280"/>
-            <a:ext cx="2377440" cy="274320"/>
+            <a:ext cx="1691640" cy="274320"/>
           </a:xfrm>
           <a:prstGeom prst="rect">
             <a:avLst/>
@@ -7970,7 +8298,7 @@
         <p:spPr>
           <a:xfrm>
             <a:off x="640080" y="3703320"/>
-            <a:ext cx="2377440" cy="822960"/>
+            <a:ext cx="1691640" cy="822960"/>
           </a:xfrm>
           <a:prstGeom prst="rect">
             <a:avLst/>
@@ -8025,8 +8353,8 @@
         </p:nvSpPr>
         <p:spPr>
           <a:xfrm>
-            <a:off x="3246120" y="2926080"/>
-            <a:ext cx="2651760" cy="1737360"/>
+            <a:off x="2560320" y="2926080"/>
+            <a:ext cx="1965960" cy="1737360"/>
           </a:xfrm>
           <a:prstGeom prst="roundRect">
             <a:avLst>
@@ -8052,8 +8380,8 @@
         </p:nvSpPr>
         <p:spPr>
           <a:xfrm>
-            <a:off x="3383280" y="3017520"/>
-            <a:ext cx="2377440" cy="365760"/>
+            <a:off x="2697480" y="3017520"/>
+            <a:ext cx="1691640" cy="365760"/>
           </a:xfrm>
           <a:prstGeom prst="rect">
             <a:avLst/>
@@ -8091,8 +8419,8 @@
         </p:nvSpPr>
         <p:spPr>
           <a:xfrm>
-            <a:off x="3383280" y="3383280"/>
-            <a:ext cx="2377440" cy="274320"/>
+            <a:off x="2697480" y="3383280"/>
+            <a:ext cx="1691640" cy="274320"/>
           </a:xfrm>
           <a:prstGeom prst="rect">
             <a:avLst/>
@@ -8130,8 +8458,8 @@
         </p:nvSpPr>
         <p:spPr>
           <a:xfrm>
-            <a:off x="3383280" y="3703320"/>
-            <a:ext cx="2377440" cy="822960"/>
+            <a:off x="2697480" y="3703320"/>
+            <a:ext cx="1691640" cy="822960"/>
           </a:xfrm>
           <a:prstGeom prst="rect">
             <a:avLst/>
@@ -8186,8 +8514,8 @@
         </p:nvSpPr>
         <p:spPr>
           <a:xfrm>
-            <a:off x="5989320" y="2926080"/>
-            <a:ext cx="2651760" cy="1737360"/>
+            <a:off x="4617720" y="2926080"/>
+            <a:ext cx="1965960" cy="1737360"/>
           </a:xfrm>
           <a:prstGeom prst="roundRect">
             <a:avLst>
@@ -8213,8 +8541,8 @@
         </p:nvSpPr>
         <p:spPr>
           <a:xfrm>
-            <a:off x="6126480" y="3017520"/>
-            <a:ext cx="2377440" cy="365760"/>
+            <a:off x="4754880" y="3017520"/>
+            <a:ext cx="1691640" cy="365760"/>
           </a:xfrm>
           <a:prstGeom prst="rect">
             <a:avLst/>
@@ -8238,7 +8566,7 @@
                 <a:ea typeface="Calibri" pitchFamily="34" charset="-122"/>
                 <a:cs typeface="Calibri" pitchFamily="34" charset="-120"/>
               </a:rPr>
-              <a:t>Hybrid CNN+MLP</a:t>
+              <a:t>Bi-GRU</a:t>
             </a:r>
             <a:endParaRPr lang="en-US" sz="1400" dirty="0"/>
           </a:p>
@@ -8252,8 +8580,8 @@
         </p:nvSpPr>
         <p:spPr>
           <a:xfrm>
-            <a:off x="6126480" y="3383280"/>
-            <a:ext cx="2377440" cy="274320"/>
+            <a:off x="4754880" y="3383280"/>
+            <a:ext cx="1691640" cy="274320"/>
           </a:xfrm>
           <a:prstGeom prst="rect">
             <a:avLst/>
@@ -8277,7 +8605,7 @@
                 <a:ea typeface="Calibri" pitchFamily="34" charset="-122"/>
                 <a:cs typeface="Calibri" pitchFamily="34" charset="-120"/>
               </a:rPr>
-              <a:t>1,49,315 params</a:t>
+              <a:t>35,331 params</a:t>
             </a:r>
             <a:endParaRPr lang="en-US" sz="1100" dirty="0"/>
           </a:p>
@@ -8291,8 +8619,169 @@
         </p:nvSpPr>
         <p:spPr>
           <a:xfrm>
-            <a:off x="6126480" y="3703320"/>
-            <a:ext cx="2377440" cy="822960"/>
+            <a:off x="4754880" y="3703320"/>
+            <a:ext cx="1691640" cy="822960"/>
+          </a:xfrm>
+          <a:prstGeom prst="rect">
+            <a:avLst/>
+          </a:prstGeom>
+          <a:noFill/>
+          <a:ln/>
+        </p:spPr>
+        <p:txBody>
+          <a:bodyPr wrap="square" lIns="0" tIns="0" rIns="0" bIns="0" rtlCol="0" anchor="t"/>
+          <a:lstStyle/>
+          <a:p>
+            <a:pPr indent="0" marL="0">
+              <a:buNone/>
+            </a:pPr>
+            <a:r>
+              <a:rPr lang="en-US" sz="1200" dirty="0">
+                <a:solidFill>
+                  <a:srgbClr val="1B1B1B"/>
+                </a:solidFill>
+                <a:latin typeface="Calibri" pitchFamily="34" charset="0"/>
+                <a:ea typeface="Calibri" pitchFamily="34" charset="-122"/>
+                <a:cs typeface="Calibri" pitchFamily="34" charset="-120"/>
+              </a:rPr>
+              <a:t>test accuracy 92.9%</a:t>
+            </a:r>
+            <a:endParaRPr lang="en-US" sz="1200" dirty="0"/>
+          </a:p>
+          <a:p>
+            <a:pPr indent="0" marL="0">
+              <a:buNone/>
+            </a:pPr>
+            <a:r>
+              <a:rPr lang="en-US" sz="1200" dirty="0">
+                <a:solidFill>
+                  <a:srgbClr val="1B1B1B"/>
+                </a:solidFill>
+                <a:latin typeface="Calibri" pitchFamily="34" charset="0"/>
+                <a:ea typeface="Calibri" pitchFamily="34" charset="-122"/>
+                <a:cs typeface="Calibri" pitchFamily="34" charset="-120"/>
+              </a:rPr>
+              <a:t>obfuscated recall 88.1%</a:t>
+            </a:r>
+            <a:endParaRPr lang="en-US" sz="1200" dirty="0"/>
+          </a:p>
+        </p:txBody>
+      </p:sp>
+      <p:sp>
+        <p:nvSpPr>
+          <p:cNvPr id="23" name="Shape 21"/>
+          <p:cNvSpPr/>
+          <p:nvPr/>
+        </p:nvSpPr>
+        <p:spPr>
+          <a:xfrm>
+            <a:off x="6675120" y="2926080"/>
+            <a:ext cx="1965960" cy="1737360"/>
+          </a:xfrm>
+          <a:prstGeom prst="roundRect">
+            <a:avLst>
+              <a:gd name="adj" fmla="val 4211"/>
+            </a:avLst>
+          </a:prstGeom>
+          <a:solidFill>
+            <a:srgbClr val="FFFFFF"/>
+          </a:solidFill>
+          <a:ln w="12700">
+            <a:solidFill>
+              <a:srgbClr val="D8DEE8"/>
+            </a:solidFill>
+            <a:prstDash val="solid"/>
+          </a:ln>
+        </p:spPr>
+      </p:sp>
+      <p:sp>
+        <p:nvSpPr>
+          <p:cNvPr id="24" name="Text 22"/>
+          <p:cNvSpPr txBox="1"/>
+          <p:nvPr/>
+        </p:nvSpPr>
+        <p:spPr>
+          <a:xfrm>
+            <a:off x="6812280" y="3017520"/>
+            <a:ext cx="1691640" cy="365760"/>
+          </a:xfrm>
+          <a:prstGeom prst="rect">
+            <a:avLst/>
+          </a:prstGeom>
+          <a:noFill/>
+          <a:ln/>
+        </p:spPr>
+        <p:txBody>
+          <a:bodyPr wrap="square" lIns="0" tIns="0" rIns="0" bIns="0" rtlCol="0" anchor="ctr"/>
+          <a:lstStyle/>
+          <a:p>
+            <a:pPr indent="0" marL="0">
+              <a:buNone/>
+            </a:pPr>
+            <a:r>
+              <a:rPr lang="en-US" sz="1400" b="1" dirty="0">
+                <a:solidFill>
+                  <a:srgbClr val="14213D"/>
+                </a:solidFill>
+                <a:latin typeface="Calibri" pitchFamily="34" charset="0"/>
+                <a:ea typeface="Calibri" pitchFamily="34" charset="-122"/>
+                <a:cs typeface="Calibri" pitchFamily="34" charset="-120"/>
+              </a:rPr>
+              <a:t>Hybrid CNN+MLP</a:t>
+            </a:r>
+            <a:endParaRPr lang="en-US" sz="1400" dirty="0"/>
+          </a:p>
+        </p:txBody>
+      </p:sp>
+      <p:sp>
+        <p:nvSpPr>
+          <p:cNvPr id="25" name="Text 23"/>
+          <p:cNvSpPr txBox="1"/>
+          <p:nvPr/>
+        </p:nvSpPr>
+        <p:spPr>
+          <a:xfrm>
+            <a:off x="6812280" y="3383280"/>
+            <a:ext cx="1691640" cy="274320"/>
+          </a:xfrm>
+          <a:prstGeom prst="rect">
+            <a:avLst/>
+          </a:prstGeom>
+          <a:noFill/>
+          <a:ln/>
+        </p:spPr>
+        <p:txBody>
+          <a:bodyPr wrap="square" lIns="0" tIns="0" rIns="0" bIns="0" rtlCol="0" anchor="ctr"/>
+          <a:lstStyle/>
+          <a:p>
+            <a:pPr indent="0" marL="0">
+              <a:buNone/>
+            </a:pPr>
+            <a:r>
+              <a:rPr lang="en-US" sz="1100" dirty="0">
+                <a:solidFill>
+                  <a:srgbClr val="5C6470"/>
+                </a:solidFill>
+                <a:latin typeface="Calibri" pitchFamily="34" charset="0"/>
+                <a:ea typeface="Calibri" pitchFamily="34" charset="-122"/>
+                <a:cs typeface="Calibri" pitchFamily="34" charset="-120"/>
+              </a:rPr>
+              <a:t>1,49,315 params</a:t>
+            </a:r>
+            <a:endParaRPr lang="en-US" sz="1100" dirty="0"/>
+          </a:p>
+        </p:txBody>
+      </p:sp>
+      <p:sp>
+        <p:nvSpPr>
+          <p:cNvPr id="26" name="Text 24"/>
+          <p:cNvSpPr txBox="1"/>
+          <p:nvPr/>
+        </p:nvSpPr>
+        <p:spPr>
+          <a:xfrm>
+            <a:off x="6812280" y="3703320"/>
+            <a:ext cx="1691640" cy="822960"/>
           </a:xfrm>
           <a:prstGeom prst="rect">
             <a:avLst/>

</xml_diff>